<commit_message>
feat(section3): add 'Default Workload' baseline option to Section 3 calculator preset dropdown
- Section 3: Added 'Default Workload (75,000 in / 8,000 out)' as the top baseline option in the preset dropdown.
- Preset Logic: Initialized calculator to Default Workload baseline on page load. Auto-updates dropdown to Default Workload when sliders are customized.
- Whitespace & Formatting: Cleaned trailing whitespace in arvocap report files.
- QA: Passed release validation suite (182/182) and Decimal pricing oracle tests (144/144).
</commit_message>
<xml_diff>
--- a/Arvocap_10k_Report_Pilot_Deck.pptx
+++ b/Arvocap_10k_Report_Pilot_Deck.pptx
@@ -3438,7 +3438,7 @@
               <a:buNone/>
             </a:pPr>
             <a:r>
-              <a:rPr lang="en-US" sz="2800" b="1" dirty="0">
+              <a:rPr lang="en-US" sz="2400" b="1" dirty="0">
                 <a:solidFill>
                   <a:srgbClr val="30D158"/>
                 </a:solidFill>
@@ -3446,9 +3446,9 @@
                 <a:ea typeface="Inter" pitchFamily="34" charset="-122"/>
                 <a:cs typeface="Inter" pitchFamily="34" charset="-120"/>
               </a:rPr>
-              <a:t>Tier 2: Standard Package</a:t>
-            </a:r>
-            <a:endParaRPr lang="en-US" sz="2800" dirty="0"/>
+              <a:t>Tier 2: Standard Package (3–6 Pages)</a:t>
+            </a:r>
+            <a:endParaRPr lang="en-US" sz="2400" dirty="0"/>
           </a:p>
         </p:txBody>
       </p:sp>
@@ -4853,7 +4853,7 @@
                 <a:ea typeface="Inter" pitchFamily="34" charset="-122"/>
                 <a:cs typeface="Inter" pitchFamily="34" charset="-120"/>
               </a:rPr>
-              <a:t>1. Page Count Drives Token Volume: A 2-page summary uses ~15,000 tokens, while a 5-page review uses ~35,000 tokens.</a:t>
+              <a:t>1. Page Count Drives Token Volume: A 1–3 page summary uses ~15,000 tokens, while a 3–6 page review uses ~35,000 tokens.</a:t>
             </a:r>
             <a:endParaRPr lang="en-US" sz="1100" dirty="0"/>
           </a:p>
@@ -4873,7 +4873,7 @@
                 <a:ea typeface="Inter" pitchFamily="34" charset="-122"/>
                 <a:cs typeface="Inter" pitchFamily="34" charset="-120"/>
               </a:rPr>
-              <a:t>2. Why We Anchor on Tier 2 (Standard Review): Without exact sample PDFs, we establish Tier 2 (3–5 Pages @ $950/mo) as our baseline benchmark.</a:t>
+              <a:t>2. Why We Anchor on Tier 2 (Standard Review): Without exact sample PDFs, we establish Tier 2 (3–6 Pages @ $950/mo) as our baseline benchmark.</a:t>
             </a:r>
             <a:endParaRPr lang="en-US" sz="1100" dirty="0"/>
           </a:p>
@@ -5314,7 +5314,7 @@
                 <a:ea typeface="Inter" pitchFamily="34" charset="-122"/>
                 <a:cs typeface="Inter" pitchFamily="34" charset="-120"/>
               </a:rPr>
-              <a:t>1 – 2 Pages</a:t>
+              <a:t>1 – 3 Pages</a:t>
             </a:r>
             <a:endParaRPr lang="en-US" sz="2200" dirty="0"/>
           </a:p>
@@ -5600,7 +5600,7 @@
                 <a:ea typeface="Inter" pitchFamily="34" charset="-122"/>
                 <a:cs typeface="Inter" pitchFamily="34" charset="-120"/>
               </a:rPr>
-              <a:t>3 – 5 Pages</a:t>
+              <a:t>3 – 6 Pages</a:t>
             </a:r>
             <a:endParaRPr lang="en-US" sz="2200" dirty="0"/>
           </a:p>
@@ -5886,7 +5886,7 @@
                 <a:ea typeface="Inter" pitchFamily="34" charset="-122"/>
                 <a:cs typeface="Inter" pitchFamily="34" charset="-120"/>
               </a:rPr>
-              <a:t>8 – 12 Pages</a:t>
+              <a:t>7 – 12 Pages</a:t>
             </a:r>
             <a:endParaRPr lang="en-US" sz="2200" dirty="0"/>
           </a:p>
@@ -6106,7 +6106,7 @@
                 <a:ea typeface="Inter" pitchFamily="34" charset="-122"/>
                 <a:cs typeface="Inter" pitchFamily="34" charset="-120"/>
               </a:rPr>
-              <a:t>NEXT NARRATIVE STEP: Let's inspect the visual structure of a Standard 3-5 Page Client Report.</a:t>
+              <a:t>NEXT NARRATIVE STEP: Let's inspect the visual structure of a Standard 3-6 Page Client Report.</a:t>
             </a:r>
             <a:endParaRPr lang="en-US" sz="850" dirty="0"/>
           </a:p>
@@ -6344,7 +6344,7 @@
                 <a:ea typeface="Inter" pitchFamily="34" charset="-122"/>
                 <a:cs typeface="Inter" pitchFamily="34" charset="-120"/>
               </a:rPr>
-              <a:t>Anatomy of a Standard 3-5 Page Client Portfolio Report</a:t>
+              <a:t>Anatomy of a Standard 3-6 Page Client Portfolio Report</a:t>
             </a:r>
             <a:endParaRPr lang="en-US" sz="2300" dirty="0"/>
           </a:p>
@@ -7238,7 +7238,7 @@
                 <a:ea typeface="Inter" pitchFamily="34" charset="-122"/>
                 <a:cs typeface="Inter" pitchFamily="34" charset="-120"/>
               </a:rPr>
-              <a:t>PAGE 5 (CONTROL)</a:t>
+              <a:t>PAGES 5–6 (CONTROL)</a:t>
             </a:r>
             <a:endParaRPr lang="en-US" sz="1000" dirty="0"/>
           </a:p>

</xml_diff>